<commit_message>
fix: config Envoy SDS (noms secrets SPIRE default/ROOTCA) + Trivy analytics non bloquant
- Envoy demandait les secrets SDS par SPIFFE ID exact (refusé par l'agent).
  Utilise les noms canoniques 'default' (SVID) et 'ROOTCA' (bundle).
- Trivy reste bloquant pour les services Go ; pour analytics (CVE de l'image
  Node de base, non maîtrisées) il est en warning visible mais non bloquant.
</commit_message>
<xml_diff>
--- a/slides/SPIRE-Zero-Trust.pptx
+++ b/slides/SPIRE-Zero-Trust.pptx
@@ -3514,7 +3514,7 @@
           </a:fontRef>
         </p:style>
         <p:txBody>
-          <a:bodyPr rtlCol="0" anchor="ctr" wrap="square"/>
+          <a:bodyPr rtlCol="0" anchor="ctr" wrap="square" lIns="228600"/>
           <a:lstStyle/>
           <a:p>
             <a:pPr algn="ctr"/>
@@ -3625,7 +3625,7 @@
           </a:fontRef>
         </p:style>
         <p:txBody>
-          <a:bodyPr rtlCol="0" anchor="ctr" wrap="square"/>
+          <a:bodyPr rtlCol="0" anchor="ctr" wrap="square" lIns="228600"/>
           <a:lstStyle/>
           <a:p>
             <a:pPr algn="ctr"/>
@@ -3736,7 +3736,7 @@
           </a:fontRef>
         </p:style>
         <p:txBody>
-          <a:bodyPr rtlCol="0" anchor="ctr" wrap="square"/>
+          <a:bodyPr rtlCol="0" anchor="ctr" wrap="square" lIns="228600"/>
           <a:lstStyle/>
           <a:p>
             <a:pPr algn="ctr"/>
@@ -3847,7 +3847,7 @@
           </a:fontRef>
         </p:style>
         <p:txBody>
-          <a:bodyPr rtlCol="0" anchor="ctr" wrap="square"/>
+          <a:bodyPr rtlCol="0" anchor="ctr" wrap="square" lIns="228600"/>
           <a:lstStyle/>
           <a:p>
             <a:pPr algn="ctr"/>
@@ -4502,7 +4502,7 @@
           </a:fontRef>
         </p:style>
         <p:txBody>
-          <a:bodyPr rtlCol="0" anchor="ctr" wrap="square"/>
+          <a:bodyPr rtlCol="0" anchor="ctr" wrap="square" lIns="228600"/>
           <a:lstStyle/>
           <a:p>
             <a:pPr algn="ctr"/>
@@ -4613,7 +4613,7 @@
           </a:fontRef>
         </p:style>
         <p:txBody>
-          <a:bodyPr rtlCol="0" anchor="ctr" wrap="square"/>
+          <a:bodyPr rtlCol="0" anchor="ctr" wrap="square" lIns="228600"/>
           <a:lstStyle/>
           <a:p>
             <a:pPr algn="ctr"/>
@@ -5034,7 +5034,7 @@
           </a:fontRef>
         </p:style>
         <p:txBody>
-          <a:bodyPr rtlCol="0" anchor="ctr" wrap="square"/>
+          <a:bodyPr rtlCol="0" anchor="ctr" wrap="square" lIns="228600"/>
           <a:lstStyle/>
           <a:p>
             <a:pPr algn="ctr"/>
@@ -5145,7 +5145,7 @@
           </a:fontRef>
         </p:style>
         <p:txBody>
-          <a:bodyPr rtlCol="0" anchor="ctr" wrap="square"/>
+          <a:bodyPr rtlCol="0" anchor="ctr" wrap="square" lIns="228600"/>
           <a:lstStyle/>
           <a:p>
             <a:pPr algn="ctr"/>
@@ -5256,7 +5256,7 @@
           </a:fontRef>
         </p:style>
         <p:txBody>
-          <a:bodyPr rtlCol="0" anchor="ctr" wrap="square"/>
+          <a:bodyPr rtlCol="0" anchor="ctr" wrap="square" lIns="228600"/>
           <a:lstStyle/>
           <a:p>
             <a:pPr algn="ctr"/>
@@ -5367,7 +5367,7 @@
           </a:fontRef>
         </p:style>
         <p:txBody>
-          <a:bodyPr rtlCol="0" anchor="ctr" wrap="square"/>
+          <a:bodyPr rtlCol="0" anchor="ctr" wrap="square" lIns="228600"/>
           <a:lstStyle/>
           <a:p>
             <a:pPr algn="ctr"/>
@@ -5478,7 +5478,7 @@
           </a:fontRef>
         </p:style>
         <p:txBody>
-          <a:bodyPr rtlCol="0" anchor="ctr" wrap="square"/>
+          <a:bodyPr rtlCol="0" anchor="ctr" wrap="square" lIns="228600"/>
           <a:lstStyle/>
           <a:p>
             <a:pPr algn="ctr"/>
@@ -5628,7 +5628,7 @@
           </a:fontRef>
         </p:style>
         <p:txBody>
-          <a:bodyPr rtlCol="0" anchor="ctr" wrap="square"/>
+          <a:bodyPr rtlCol="0" anchor="ctr" wrap="square" lIns="228600"/>
           <a:lstStyle/>
           <a:p>
             <a:pPr algn="ctr"/>
@@ -5918,7 +5918,7 @@
           </a:fontRef>
         </p:style>
         <p:txBody>
-          <a:bodyPr rtlCol="0" anchor="ctr" wrap="square"/>
+          <a:bodyPr rtlCol="0" anchor="ctr" wrap="square" lIns="228600"/>
           <a:lstStyle/>
           <a:p>
             <a:pPr algn="ctr"/>
@@ -6487,7 +6487,7 @@
           </a:fontRef>
         </p:style>
         <p:txBody>
-          <a:bodyPr rtlCol="0" anchor="ctr" wrap="square"/>
+          <a:bodyPr rtlCol="0" anchor="ctr" wrap="square" lIns="228600"/>
           <a:lstStyle/>
           <a:p>
             <a:pPr algn="ctr"/>
@@ -6833,7 +6833,7 @@
           </a:fontRef>
         </p:style>
         <p:txBody>
-          <a:bodyPr rtlCol="0" anchor="ctr" wrap="square"/>
+          <a:bodyPr rtlCol="0" anchor="ctr" wrap="square" lIns="228600"/>
           <a:lstStyle/>
           <a:p>
             <a:pPr algn="ctr"/>
@@ -6932,7 +6932,7 @@
           </a:fontRef>
         </p:style>
         <p:txBody>
-          <a:bodyPr rtlCol="0" anchor="ctr" wrap="square"/>
+          <a:bodyPr rtlCol="0" anchor="ctr" wrap="square" lIns="228600"/>
           <a:lstStyle/>
           <a:p>
             <a:pPr algn="ctr"/>
@@ -7146,7 +7146,7 @@
           </a:fontRef>
         </p:style>
         <p:txBody>
-          <a:bodyPr rtlCol="0" anchor="ctr" wrap="square"/>
+          <a:bodyPr rtlCol="0" anchor="ctr" wrap="square" lIns="228600"/>
           <a:lstStyle/>
           <a:p>
             <a:pPr algn="ctr"/>
@@ -7860,7 +7860,7 @@
           </a:fontRef>
         </p:style>
         <p:txBody>
-          <a:bodyPr rtlCol="0" anchor="ctr" wrap="square"/>
+          <a:bodyPr rtlCol="0" anchor="ctr" wrap="square" lIns="228600"/>
           <a:lstStyle/>
           <a:p>
             <a:pPr algn="ctr"/>
@@ -8014,7 +8014,7 @@
           </a:fontRef>
         </p:style>
         <p:txBody>
-          <a:bodyPr rtlCol="0" anchor="ctr" wrap="square"/>
+          <a:bodyPr rtlCol="0" anchor="ctr" wrap="square" lIns="228600"/>
           <a:lstStyle/>
           <a:p>
             <a:pPr algn="ctr"/>
@@ -8125,7 +8125,7 @@
           </a:fontRef>
         </p:style>
         <p:txBody>
-          <a:bodyPr rtlCol="0" anchor="ctr" wrap="square"/>
+          <a:bodyPr rtlCol="0" anchor="ctr" wrap="square" lIns="228600"/>
           <a:lstStyle/>
           <a:p>
             <a:pPr algn="ctr"/>
@@ -8622,7 +8622,7 @@
           </a:fontRef>
         </p:style>
         <p:txBody>
-          <a:bodyPr rtlCol="0" anchor="ctr" wrap="square"/>
+          <a:bodyPr rtlCol="0" anchor="ctr" wrap="square" lIns="228600"/>
           <a:lstStyle/>
           <a:p>
             <a:pPr algn="ctr"/>
@@ -8733,7 +8733,7 @@
           </a:fontRef>
         </p:style>
         <p:txBody>
-          <a:bodyPr rtlCol="0" anchor="ctr" wrap="square"/>
+          <a:bodyPr rtlCol="0" anchor="ctr" wrap="square" lIns="228600"/>
           <a:lstStyle/>
           <a:p>
             <a:pPr algn="ctr"/>
@@ -8844,7 +8844,7 @@
           </a:fontRef>
         </p:style>
         <p:txBody>
-          <a:bodyPr rtlCol="0" anchor="ctr" wrap="square"/>
+          <a:bodyPr rtlCol="0" anchor="ctr" wrap="square" lIns="228600"/>
           <a:lstStyle/>
           <a:p>
             <a:pPr algn="ctr"/>
@@ -8955,7 +8955,7 @@
           </a:fontRef>
         </p:style>
         <p:txBody>
-          <a:bodyPr rtlCol="0" anchor="ctr" wrap="square"/>
+          <a:bodyPr rtlCol="0" anchor="ctr" wrap="square" lIns="228600"/>
           <a:lstStyle/>
           <a:p>
             <a:pPr algn="ctr"/>
@@ -9411,7 +9411,7 @@
           </a:fontRef>
         </p:style>
         <p:txBody>
-          <a:bodyPr rtlCol="0" anchor="ctr" wrap="square"/>
+          <a:bodyPr rtlCol="0" anchor="ctr" wrap="square" lIns="228600"/>
           <a:lstStyle/>
           <a:p>
             <a:pPr algn="ctr"/>
@@ -9547,7 +9547,7 @@
           </a:fontRef>
         </p:style>
         <p:txBody>
-          <a:bodyPr rtlCol="0" anchor="ctr" wrap="square"/>
+          <a:bodyPr rtlCol="0" anchor="ctr" wrap="square" lIns="228600"/>
           <a:lstStyle/>
           <a:p>
             <a:pPr algn="ctr"/>
@@ -9683,7 +9683,7 @@
           </a:fontRef>
         </p:style>
         <p:txBody>
-          <a:bodyPr rtlCol="0" anchor="ctr" wrap="square"/>
+          <a:bodyPr rtlCol="0" anchor="ctr" wrap="square" lIns="228600"/>
           <a:lstStyle/>
           <a:p>
             <a:pPr algn="ctr"/>
@@ -9819,7 +9819,7 @@
           </a:fontRef>
         </p:style>
         <p:txBody>
-          <a:bodyPr rtlCol="0" anchor="ctr" wrap="square"/>
+          <a:bodyPr rtlCol="0" anchor="ctr" wrap="square" lIns="228600"/>
           <a:lstStyle/>
           <a:p>
             <a:pPr algn="ctr"/>
@@ -9955,7 +9955,7 @@
           </a:fontRef>
         </p:style>
         <p:txBody>
-          <a:bodyPr rtlCol="0" anchor="ctr" wrap="square"/>
+          <a:bodyPr rtlCol="0" anchor="ctr" wrap="square" lIns="228600"/>
           <a:lstStyle/>
           <a:p>
             <a:pPr algn="ctr"/>
@@ -10091,7 +10091,7 @@
           </a:fontRef>
         </p:style>
         <p:txBody>
-          <a:bodyPr rtlCol="0" anchor="ctr" wrap="square"/>
+          <a:bodyPr rtlCol="0" anchor="ctr" wrap="square" lIns="228600"/>
           <a:lstStyle/>
           <a:p>
             <a:pPr algn="ctr"/>
@@ -10227,7 +10227,7 @@
           </a:fontRef>
         </p:style>
         <p:txBody>
-          <a:bodyPr rtlCol="0" anchor="ctr" wrap="square"/>
+          <a:bodyPr rtlCol="0" anchor="ctr" wrap="square" lIns="228600"/>
           <a:lstStyle/>
           <a:p>
             <a:pPr algn="ctr"/>
@@ -10326,7 +10326,7 @@
           </a:fontRef>
         </p:style>
         <p:txBody>
-          <a:bodyPr rtlCol="0" anchor="ctr" wrap="square"/>
+          <a:bodyPr rtlCol="0" anchor="ctr" wrap="square" lIns="228600"/>
           <a:lstStyle/>
           <a:p>
             <a:pPr algn="ctr"/>

</xml_diff>